<commit_message>
Deck: real cost figures, and a correction
The cost slide said Amazon's reporting showed no service charges for
August or September. That was wrong, and wrong because of how I asked:
the query ended on 13 September and Cost Explorer excludes its end date,
so it cut off the only day charges had posted.

Actual figures, from the account:

  Route 53 hosted zone         $0.50 / month  (the only real charge)
  DNS lookups, 2,205 of them   $0.0009
  Amplify, S3, Lambda,
  DynamoDB, Cognito, API GW    $0.0004 between them
  September to date            $0.50
  August                       $0.00
  austinareafirewise.org       $16.00 / year, renews 12 Sep 2027

About $22 a year at today's traffic. Text messages are not billed yet --
the toll-free number is still in verification -- and are the one line
that will grow.

Co-Authored-By: Claude Opus 5 <noreply@anthropic.com>
</commit_message>
<xml_diff>
--- a/docs/AAFA-website-overview.pptx
+++ b/docs/AAFA-website-overview.pptx
@@ -3817,7 +3817,7 @@
                 </a:solidFill>
                 <a:latin typeface="Trebuchet MS"/>
               </a:rPr>
-              <a:t>MONEY</a:t>
+              <a:t>MONEY — ACTUAL FIGURES FROM THE BILL</a:t>
             </a:r>
           </a:p>
         </p:txBody>
@@ -3909,8 +3909,8 @@
         </p:nvSpPr>
         <p:spPr>
           <a:xfrm>
-            <a:off x="777240" y="1965960"/>
-            <a:ext cx="10607040" cy="4114800"/>
+            <a:off x="777240" y="1719072"/>
+            <a:ext cx="7863840" cy="411480"/>
           </a:xfrm>
           <a:prstGeom prst="rect">
             <a:avLst/>
@@ -3923,187 +3923,703 @@
           </a:bodyPr>
           <a:lstStyle/>
           <a:p>
-            <a:pPr algn="l">
-              <a:spcAft>
-                <a:spcPts val="1400"/>
-              </a:spcAft>
-            </a:pPr>
-            <a:r>
-              <a:rPr sz="1600" b="1" i="0">
-                <a:solidFill>
-                  <a:srgbClr val="DA7B37"/>
-                </a:solidFill>
-                <a:latin typeface="Trebuchet MS"/>
-              </a:rPr>
-              <a:t>▪  </a:t>
-            </a:r>
-            <a:r>
-              <a:rPr sz="1600" b="1" i="0">
+            <a:pPr algn="l"/>
+            <a:r>
+              <a:rPr sz="1500" b="0" i="0">
+                <a:solidFill>
+                  <a:srgbClr val="1D2A21"/>
+                </a:solidFill>
+                <a:latin typeface="Trebuchet MS"/>
+              </a:rPr>
+              <a:t>Route 53 hosted zone</a:t>
+            </a:r>
+          </a:p>
+        </p:txBody>
+      </p:sp>
+      <p:sp>
+        <p:nvSpPr>
+          <p:cNvPr id="7" name="TextBox 6"/>
+          <p:cNvSpPr txBox="1"/>
+          <p:nvPr/>
+        </p:nvSpPr>
+        <p:spPr>
+          <a:xfrm>
+            <a:off x="777240" y="1956815"/>
+            <a:ext cx="7863840" cy="320040"/>
+          </a:xfrm>
+          <a:prstGeom prst="rect">
+            <a:avLst/>
+          </a:prstGeom>
+          <a:noFill/>
+        </p:spPr>
+        <p:txBody>
+          <a:bodyPr wrap="square">
+            <a:spAutoFit/>
+          </a:bodyPr>
+          <a:lstStyle/>
+          <a:p>
+            <a:pPr algn="l"/>
+            <a:r>
+              <a:rPr sz="1100" b="0" i="0">
+                <a:solidFill>
+                  <a:srgbClr val="556666"/>
+                </a:solidFill>
+                <a:latin typeface="Trebuchet MS"/>
+              </a:rPr>
+              <a:t>The fixed charge for holding the domain’s address records. The only charge that is not pennies.</a:t>
+            </a:r>
+          </a:p>
+        </p:txBody>
+      </p:sp>
+      <p:sp>
+        <p:nvSpPr>
+          <p:cNvPr id="8" name="TextBox 7"/>
+          <p:cNvSpPr txBox="1"/>
+          <p:nvPr/>
+        </p:nvSpPr>
+        <p:spPr>
+          <a:xfrm>
+            <a:off x="8778240" y="1719072"/>
+            <a:ext cx="2606040" cy="411480"/>
+          </a:xfrm>
+          <a:prstGeom prst="rect">
+            <a:avLst/>
+          </a:prstGeom>
+          <a:noFill/>
+        </p:spPr>
+        <p:txBody>
+          <a:bodyPr wrap="square">
+            <a:spAutoFit/>
+          </a:bodyPr>
+          <a:lstStyle/>
+          <a:p>
+            <a:pPr algn="r"/>
+            <a:r>
+              <a:rPr sz="1500" b="0" i="0">
+                <a:solidFill>
+                  <a:srgbClr val="1D2A21"/>
+                </a:solidFill>
+                <a:latin typeface="Trebuchet MS"/>
+              </a:rPr>
+              <a:t>$0.50 / month</a:t>
+            </a:r>
+          </a:p>
+        </p:txBody>
+      </p:sp>
+      <p:sp>
+        <p:nvSpPr>
+          <p:cNvPr id="9" name="TextBox 8"/>
+          <p:cNvSpPr txBox="1"/>
+          <p:nvPr/>
+        </p:nvSpPr>
+        <p:spPr>
+          <a:xfrm>
+            <a:off x="777240" y="2322576"/>
+            <a:ext cx="7863840" cy="411480"/>
+          </a:xfrm>
+          <a:prstGeom prst="rect">
+            <a:avLst/>
+          </a:prstGeom>
+          <a:noFill/>
+        </p:spPr>
+        <p:txBody>
+          <a:bodyPr wrap="square">
+            <a:spAutoFit/>
+          </a:bodyPr>
+          <a:lstStyle/>
+          <a:p>
+            <a:pPr algn="l"/>
+            <a:r>
+              <a:rPr sz="1500" b="0" i="0">
+                <a:solidFill>
+                  <a:srgbClr val="1D2A21"/>
+                </a:solidFill>
+                <a:latin typeface="Trebuchet MS"/>
+              </a:rPr>
+              <a:t>DNS lookups — 2,205 of them so far</a:t>
+            </a:r>
+          </a:p>
+        </p:txBody>
+      </p:sp>
+      <p:sp>
+        <p:nvSpPr>
+          <p:cNvPr id="10" name="TextBox 9"/>
+          <p:cNvSpPr txBox="1"/>
+          <p:nvPr/>
+        </p:nvSpPr>
+        <p:spPr>
+          <a:xfrm>
+            <a:off x="8778240" y="2322576"/>
+            <a:ext cx="2606040" cy="411480"/>
+          </a:xfrm>
+          <a:prstGeom prst="rect">
+            <a:avLst/>
+          </a:prstGeom>
+          <a:noFill/>
+        </p:spPr>
+        <p:txBody>
+          <a:bodyPr wrap="square">
+            <a:spAutoFit/>
+          </a:bodyPr>
+          <a:lstStyle/>
+          <a:p>
+            <a:pPr algn="r"/>
+            <a:r>
+              <a:rPr sz="1500" b="0" i="0">
+                <a:solidFill>
+                  <a:srgbClr val="1D2A21"/>
+                </a:solidFill>
+                <a:latin typeface="Trebuchet MS"/>
+              </a:rPr>
+              <a:t>$0.0009</a:t>
+            </a:r>
+          </a:p>
+        </p:txBody>
+      </p:sp>
+      <p:sp>
+        <p:nvSpPr>
+          <p:cNvPr id="11" name="TextBox 10"/>
+          <p:cNvSpPr txBox="1"/>
+          <p:nvPr/>
+        </p:nvSpPr>
+        <p:spPr>
+          <a:xfrm>
+            <a:off x="777240" y="2724912"/>
+            <a:ext cx="7863840" cy="411480"/>
+          </a:xfrm>
+          <a:prstGeom prst="rect">
+            <a:avLst/>
+          </a:prstGeom>
+          <a:noFill/>
+        </p:spPr>
+        <p:txBody>
+          <a:bodyPr wrap="square">
+            <a:spAutoFit/>
+          </a:bodyPr>
+          <a:lstStyle/>
+          <a:p>
+            <a:pPr algn="l"/>
+            <a:r>
+              <a:rPr sz="1500" b="0" i="0">
+                <a:solidFill>
+                  <a:srgbClr val="1D2A21"/>
+                </a:solidFill>
+                <a:latin typeface="Trebuchet MS"/>
+              </a:rPr>
+              <a:t>Amplify, S3, Lambda, DynamoDB, Cognito, API Gateway</a:t>
+            </a:r>
+          </a:p>
+        </p:txBody>
+      </p:sp>
+      <p:sp>
+        <p:nvSpPr>
+          <p:cNvPr id="12" name="TextBox 11"/>
+          <p:cNvSpPr txBox="1"/>
+          <p:nvPr/>
+        </p:nvSpPr>
+        <p:spPr>
+          <a:xfrm>
+            <a:off x="777240" y="2962656"/>
+            <a:ext cx="7863840" cy="320040"/>
+          </a:xfrm>
+          <a:prstGeom prst="rect">
+            <a:avLst/>
+          </a:prstGeom>
+          <a:noFill/>
+        </p:spPr>
+        <p:txBody>
+          <a:bodyPr wrap="square">
+            <a:spAutoFit/>
+          </a:bodyPr>
+          <a:lstStyle/>
+          <a:p>
+            <a:pPr algn="l"/>
+            <a:r>
+              <a:rPr sz="1100" b="0" i="0">
+                <a:solidFill>
+                  <a:srgbClr val="556666"/>
+                </a:solidFill>
+                <a:latin typeface="Trebuchet MS"/>
+              </a:rPr>
+              <a:t>All six together, for the month to date.</a:t>
+            </a:r>
+          </a:p>
+        </p:txBody>
+      </p:sp>
+      <p:sp>
+        <p:nvSpPr>
+          <p:cNvPr id="13" name="TextBox 12"/>
+          <p:cNvSpPr txBox="1"/>
+          <p:nvPr/>
+        </p:nvSpPr>
+        <p:spPr>
+          <a:xfrm>
+            <a:off x="8778240" y="2724912"/>
+            <a:ext cx="2606040" cy="411480"/>
+          </a:xfrm>
+          <a:prstGeom prst="rect">
+            <a:avLst/>
+          </a:prstGeom>
+          <a:noFill/>
+        </p:spPr>
+        <p:txBody>
+          <a:bodyPr wrap="square">
+            <a:spAutoFit/>
+          </a:bodyPr>
+          <a:lstStyle/>
+          <a:p>
+            <a:pPr algn="r"/>
+            <a:r>
+              <a:rPr sz="1500" b="0" i="0">
+                <a:solidFill>
+                  <a:srgbClr val="1D2A21"/>
+                </a:solidFill>
+                <a:latin typeface="Trebuchet MS"/>
+              </a:rPr>
+              <a:t>$0.0004</a:t>
+            </a:r>
+          </a:p>
+        </p:txBody>
+      </p:sp>
+      <p:sp>
+        <p:nvSpPr>
+          <p:cNvPr id="14" name="Rectangle 13"/>
+          <p:cNvSpPr/>
+          <p:nvPr/>
+        </p:nvSpPr>
+        <p:spPr>
+          <a:xfrm>
+            <a:off x="777240" y="3328416"/>
+            <a:ext cx="10607040" cy="12700"/>
+          </a:xfrm>
+          <a:prstGeom prst="rect">
+            <a:avLst/>
+          </a:prstGeom>
+          <a:solidFill>
+            <a:srgbClr val="E2E0D8"/>
+          </a:solidFill>
+          <a:ln>
+            <a:noFill/>
+          </a:ln>
+          <a:effectLst/>
+        </p:spPr>
+        <p:style>
+          <a:lnRef idx="1">
+            <a:schemeClr val="accent1"/>
+          </a:lnRef>
+          <a:fillRef idx="3">
+            <a:schemeClr val="accent1"/>
+          </a:fillRef>
+          <a:effectRef idx="2">
+            <a:schemeClr val="accent1"/>
+          </a:effectRef>
+          <a:fontRef idx="minor">
+            <a:schemeClr val="lt1"/>
+          </a:fontRef>
+        </p:style>
+        <p:txBody>
+          <a:bodyPr rtlCol="0" anchor="ctr"/>
+          <a:lstStyle/>
+          <a:p>
+            <a:pPr algn="ctr"/>
+          </a:p>
+        </p:txBody>
+      </p:sp>
+      <p:sp>
+        <p:nvSpPr>
+          <p:cNvPr id="15" name="TextBox 14"/>
+          <p:cNvSpPr txBox="1"/>
+          <p:nvPr/>
+        </p:nvSpPr>
+        <p:spPr>
+          <a:xfrm>
+            <a:off x="777240" y="3474720"/>
+            <a:ext cx="7863840" cy="411480"/>
+          </a:xfrm>
+          <a:prstGeom prst="rect">
+            <a:avLst/>
+          </a:prstGeom>
+          <a:noFill/>
+        </p:spPr>
+        <p:txBody>
+          <a:bodyPr wrap="square">
+            <a:spAutoFit/>
+          </a:bodyPr>
+          <a:lstStyle/>
+          <a:p>
+            <a:pPr algn="l"/>
+            <a:r>
+              <a:rPr sz="1500" b="1" i="0">
                 <a:solidFill>
                   <a:srgbClr val="19462B"/>
                 </a:solidFill>
                 <a:latin typeface="Trebuchet MS"/>
               </a:rPr>
-              <a:t>Hosting, ledger and helpers.</a:t>
-            </a:r>
-            <a:r>
-              <a:rPr sz="1600" b="0" i="0">
+              <a:t>September so far — everything</a:t>
+            </a:r>
+          </a:p>
+        </p:txBody>
+      </p:sp>
+      <p:sp>
+        <p:nvSpPr>
+          <p:cNvPr id="16" name="TextBox 15"/>
+          <p:cNvSpPr txBox="1"/>
+          <p:nvPr/>
+        </p:nvSpPr>
+        <p:spPr>
+          <a:xfrm>
+            <a:off x="8778240" y="3474720"/>
+            <a:ext cx="2606040" cy="411480"/>
+          </a:xfrm>
+          <a:prstGeom prst="rect">
+            <a:avLst/>
+          </a:prstGeom>
+          <a:noFill/>
+        </p:spPr>
+        <p:txBody>
+          <a:bodyPr wrap="square">
+            <a:spAutoFit/>
+          </a:bodyPr>
+          <a:lstStyle/>
+          <a:p>
+            <a:pPr algn="r"/>
+            <a:r>
+              <a:rPr sz="1500" b="1" i="0">
+                <a:solidFill>
+                  <a:srgbClr val="265438"/>
+                </a:solidFill>
+                <a:latin typeface="Trebuchet MS"/>
+              </a:rPr>
+              <a:t>$0.50</a:t>
+            </a:r>
+          </a:p>
+        </p:txBody>
+      </p:sp>
+      <p:sp>
+        <p:nvSpPr>
+          <p:cNvPr id="17" name="TextBox 16"/>
+          <p:cNvSpPr txBox="1"/>
+          <p:nvPr/>
+        </p:nvSpPr>
+        <p:spPr>
+          <a:xfrm>
+            <a:off x="777240" y="3895344"/>
+            <a:ext cx="7863840" cy="411480"/>
+          </a:xfrm>
+          <a:prstGeom prst="rect">
+            <a:avLst/>
+          </a:prstGeom>
+          <a:noFill/>
+        </p:spPr>
+        <p:txBody>
+          <a:bodyPr wrap="square">
+            <a:spAutoFit/>
+          </a:bodyPr>
+          <a:lstStyle/>
+          <a:p>
+            <a:pPr algn="l"/>
+            <a:r>
+              <a:rPr sz="1500" b="0" i="0">
                 <a:solidFill>
                   <a:srgbClr val="1D2A21"/>
                 </a:solidFill>
                 <a:latin typeface="Trebuchet MS"/>
               </a:rPr>
-              <a:t>  Comfortably inside the free allowances Amazon gives an organisation our size.</a:t>
-            </a:r>
-          </a:p>
-          <a:p>
-            <a:pPr>
-              <a:spcAft>
-                <a:spcPts val="1400"/>
-              </a:spcAft>
-            </a:pPr>
-            <a:r>
-              <a:rPr sz="1600" b="1" i="0">
-                <a:solidFill>
-                  <a:srgbClr val="DA7B37"/>
-                </a:solidFill>
-                <a:latin typeface="Trebuchet MS"/>
-              </a:rPr>
-              <a:t>▪  </a:t>
-            </a:r>
-            <a:r>
-              <a:rPr sz="1600" b="1" i="0">
-                <a:solidFill>
-                  <a:srgbClr val="19462B"/>
-                </a:solidFill>
-                <a:latin typeface="Trebuchet MS"/>
-              </a:rPr>
-              <a:t>The bill so far.</a:t>
-            </a:r>
-            <a:r>
-              <a:rPr sz="1600" b="0" i="0">
+              <a:t>August</a:t>
+            </a:r>
+          </a:p>
+        </p:txBody>
+      </p:sp>
+      <p:sp>
+        <p:nvSpPr>
+          <p:cNvPr id="18" name="TextBox 17"/>
+          <p:cNvSpPr txBox="1"/>
+          <p:nvPr/>
+        </p:nvSpPr>
+        <p:spPr>
+          <a:xfrm>
+            <a:off x="777240" y="4133088"/>
+            <a:ext cx="7863840" cy="320040"/>
+          </a:xfrm>
+          <a:prstGeom prst="rect">
+            <a:avLst/>
+          </a:prstGeom>
+          <a:noFill/>
+        </p:spPr>
+        <p:txBody>
+          <a:bodyPr wrap="square">
+            <a:spAutoFit/>
+          </a:bodyPr>
+          <a:lstStyle/>
+          <a:p>
+            <a:pPr algn="l"/>
+            <a:r>
+              <a:rPr sz="1100" b="0" i="0">
+                <a:solidFill>
+                  <a:srgbClr val="556666"/>
+                </a:solidFill>
+                <a:latin typeface="Trebuchet MS"/>
+              </a:rPr>
+              <a:t>Nothing was running yet.</a:t>
+            </a:r>
+          </a:p>
+        </p:txBody>
+      </p:sp>
+      <p:sp>
+        <p:nvSpPr>
+          <p:cNvPr id="19" name="TextBox 18"/>
+          <p:cNvSpPr txBox="1"/>
+          <p:nvPr/>
+        </p:nvSpPr>
+        <p:spPr>
+          <a:xfrm>
+            <a:off x="8778240" y="3895344"/>
+            <a:ext cx="2606040" cy="411480"/>
+          </a:xfrm>
+          <a:prstGeom prst="rect">
+            <a:avLst/>
+          </a:prstGeom>
+          <a:noFill/>
+        </p:spPr>
+        <p:txBody>
+          <a:bodyPr wrap="square">
+            <a:spAutoFit/>
+          </a:bodyPr>
+          <a:lstStyle/>
+          <a:p>
+            <a:pPr algn="r"/>
+            <a:r>
+              <a:rPr sz="1500" b="0" i="0">
                 <a:solidFill>
                   <a:srgbClr val="1D2A21"/>
                 </a:solidFill>
                 <a:latin typeface="Trebuchet MS"/>
               </a:rPr>
-              <a:t>  Amazon’s cost reporting shows no service charges for August, or for September to date.</a:t>
-            </a:r>
-          </a:p>
-          <a:p>
-            <a:pPr>
-              <a:spcAft>
-                <a:spcPts val="1400"/>
-              </a:spcAft>
-            </a:pPr>
-            <a:r>
-              <a:rPr sz="1600" b="1" i="0">
-                <a:solidFill>
-                  <a:srgbClr val="DA7B37"/>
-                </a:solidFill>
-                <a:latin typeface="Trebuchet MS"/>
-              </a:rPr>
-              <a:t>▪  </a:t>
-            </a:r>
-            <a:r>
-              <a:rPr sz="1600" b="1" i="0">
-                <a:solidFill>
-                  <a:srgbClr val="19462B"/>
-                </a:solidFill>
-                <a:latin typeface="Trebuchet MS"/>
-              </a:rPr>
-              <a:t>The domain name.</a:t>
-            </a:r>
-            <a:r>
-              <a:rPr sz="1600" b="0" i="0">
+              <a:t>$0.00</a:t>
+            </a:r>
+          </a:p>
+        </p:txBody>
+      </p:sp>
+      <p:sp>
+        <p:nvSpPr>
+          <p:cNvPr id="20" name="TextBox 19"/>
+          <p:cNvSpPr txBox="1"/>
+          <p:nvPr/>
+        </p:nvSpPr>
+        <p:spPr>
+          <a:xfrm>
+            <a:off x="777240" y="4480560"/>
+            <a:ext cx="7863840" cy="411480"/>
+          </a:xfrm>
+          <a:prstGeom prst="rect">
+            <a:avLst/>
+          </a:prstGeom>
+          <a:noFill/>
+        </p:spPr>
+        <p:txBody>
+          <a:bodyPr wrap="square">
+            <a:spAutoFit/>
+          </a:bodyPr>
+          <a:lstStyle/>
+          <a:p>
+            <a:pPr algn="l"/>
+            <a:r>
+              <a:rPr sz="1500" b="0" i="0">
                 <a:solidFill>
                   <a:srgbClr val="1D2A21"/>
                 </a:solidFill>
                 <a:latin typeface="Trebuchet MS"/>
               </a:rPr>
-              <a:t>  austinareafirewise.org renews on 12 September 2027, set to renew automatically. An annual registration fee is the one certain cost.</a:t>
-            </a:r>
-          </a:p>
-          <a:p>
-            <a:pPr>
-              <a:spcAft>
-                <a:spcPts val="1400"/>
-              </a:spcAft>
-            </a:pPr>
-            <a:r>
-              <a:rPr sz="1600" b="1" i="0">
-                <a:solidFill>
-                  <a:srgbClr val="DA7B37"/>
-                </a:solidFill>
-                <a:latin typeface="Trebuchet MS"/>
-              </a:rPr>
-              <a:t>▪  </a:t>
-            </a:r>
-            <a:r>
-              <a:rPr sz="1600" b="1" i="0">
-                <a:solidFill>
-                  <a:srgbClr val="19462B"/>
-                </a:solidFill>
-                <a:latin typeface="Trebuchet MS"/>
-              </a:rPr>
-              <a:t>Email.</a:t>
-            </a:r>
-            <a:r>
-              <a:rPr sz="1600" b="0" i="0">
+              <a:t>austinareafirewise.org — registration and renewal</a:t>
+            </a:r>
+          </a:p>
+        </p:txBody>
+      </p:sp>
+      <p:sp>
+        <p:nvSpPr>
+          <p:cNvPr id="21" name="TextBox 20"/>
+          <p:cNvSpPr txBox="1"/>
+          <p:nvPr/>
+        </p:nvSpPr>
+        <p:spPr>
+          <a:xfrm>
+            <a:off x="777240" y="4718304"/>
+            <a:ext cx="7863840" cy="320040"/>
+          </a:xfrm>
+          <a:prstGeom prst="rect">
+            <a:avLst/>
+          </a:prstGeom>
+          <a:noFill/>
+        </p:spPr>
+        <p:txBody>
+          <a:bodyPr wrap="square">
+            <a:spAutoFit/>
+          </a:bodyPr>
+          <a:lstStyle/>
+          <a:p>
+            <a:pPr algn="l"/>
+            <a:r>
+              <a:rPr sz="1100" b="0" i="0">
+                <a:solidFill>
+                  <a:srgbClr val="556666"/>
+                </a:solidFill>
+                <a:latin typeface="Trebuchet MS"/>
+              </a:rPr>
+              <a:t>Amazon’s current .org price. Renews 12 September 2027, automatically. Not yet on the bill.</a:t>
+            </a:r>
+          </a:p>
+        </p:txBody>
+      </p:sp>
+      <p:sp>
+        <p:nvSpPr>
+          <p:cNvPr id="22" name="TextBox 21"/>
+          <p:cNvSpPr txBox="1"/>
+          <p:nvPr/>
+        </p:nvSpPr>
+        <p:spPr>
+          <a:xfrm>
+            <a:off x="8778240" y="4480560"/>
+            <a:ext cx="2606040" cy="411480"/>
+          </a:xfrm>
+          <a:prstGeom prst="rect">
+            <a:avLst/>
+          </a:prstGeom>
+          <a:noFill/>
+        </p:spPr>
+        <p:txBody>
+          <a:bodyPr wrap="square">
+            <a:spAutoFit/>
+          </a:bodyPr>
+          <a:lstStyle/>
+          <a:p>
+            <a:pPr algn="r"/>
+            <a:r>
+              <a:rPr sz="1500" b="0" i="0">
                 <a:solidFill>
                   <a:srgbClr val="1D2A21"/>
                 </a:solidFill>
                 <a:latin typeface="Trebuchet MS"/>
               </a:rPr>
-              <a:t>  Free at the volumes we send.</a:t>
-            </a:r>
-          </a:p>
-          <a:p>
-            <a:pPr>
-              <a:spcAft>
-                <a:spcPts val="1400"/>
-              </a:spcAft>
-            </a:pPr>
-            <a:r>
-              <a:rPr sz="1600" b="1" i="0">
-                <a:solidFill>
-                  <a:srgbClr val="DA7B37"/>
-                </a:solidFill>
-                <a:latin typeface="Trebuchet MS"/>
-              </a:rPr>
-              <a:t>▪  </a:t>
-            </a:r>
-            <a:r>
-              <a:rPr sz="1600" b="1" i="0">
-                <a:solidFill>
-                  <a:srgbClr val="19462B"/>
-                </a:solidFill>
-                <a:latin typeface="Trebuchet MS"/>
-              </a:rPr>
-              <a:t>Text messages.</a:t>
-            </a:r>
-            <a:r>
-              <a:rPr sz="1600" b="0" i="0">
+              <a:t>$16.00 / year</a:t>
+            </a:r>
+          </a:p>
+        </p:txBody>
+      </p:sp>
+      <p:sp>
+        <p:nvSpPr>
+          <p:cNvPr id="23" name="TextBox 22"/>
+          <p:cNvSpPr txBox="1"/>
+          <p:nvPr/>
+        </p:nvSpPr>
+        <p:spPr>
+          <a:xfrm>
+            <a:off x="777240" y="5065776"/>
+            <a:ext cx="7863840" cy="411480"/>
+          </a:xfrm>
+          <a:prstGeom prst="rect">
+            <a:avLst/>
+          </a:prstGeom>
+          <a:noFill/>
+        </p:spPr>
+        <p:txBody>
+          <a:bodyPr wrap="square">
+            <a:spAutoFit/>
+          </a:bodyPr>
+          <a:lstStyle/>
+          <a:p>
+            <a:pPr algn="l"/>
+            <a:r>
+              <a:rPr sz="1500" b="0" i="0">
                 <a:solidFill>
                   <a:srgbClr val="1D2A21"/>
                 </a:solidFill>
                 <a:latin typeface="Trebuchet MS"/>
               </a:rPr>
-              <a:t>  A small monthly fee for the toll-free number, plus a few cents a message, once verification completes.</a:t>
-            </a:r>
-          </a:p>
-        </p:txBody>
-      </p:sp>
-      <p:sp>
-        <p:nvSpPr>
-          <p:cNvPr id="7" name="Rounded Rectangle 6"/>
+              <a:t>Text messages</a:t>
+            </a:r>
+          </a:p>
+        </p:txBody>
+      </p:sp>
+      <p:sp>
+        <p:nvSpPr>
+          <p:cNvPr id="24" name="TextBox 23"/>
+          <p:cNvSpPr txBox="1"/>
+          <p:nvPr/>
+        </p:nvSpPr>
+        <p:spPr>
+          <a:xfrm>
+            <a:off x="777240" y="5303520"/>
+            <a:ext cx="7863840" cy="320040"/>
+          </a:xfrm>
+          <a:prstGeom prst="rect">
+            <a:avLst/>
+          </a:prstGeom>
+          <a:noFill/>
+        </p:spPr>
+        <p:txBody>
+          <a:bodyPr wrap="square">
+            <a:spAutoFit/>
+          </a:bodyPr>
+          <a:lstStyle/>
+          <a:p>
+            <a:pPr algn="l"/>
+            <a:r>
+              <a:rPr sz="1100" b="0" i="0">
+                <a:solidFill>
+                  <a:srgbClr val="556666"/>
+                </a:solidFill>
+                <a:latin typeface="Trebuchet MS"/>
+              </a:rPr>
+              <a:t>The toll-free number is still being verified. Charges start when it goes live.</a:t>
+            </a:r>
+          </a:p>
+        </p:txBody>
+      </p:sp>
+      <p:sp>
+        <p:nvSpPr>
+          <p:cNvPr id="25" name="TextBox 24"/>
+          <p:cNvSpPr txBox="1"/>
+          <p:nvPr/>
+        </p:nvSpPr>
+        <p:spPr>
+          <a:xfrm>
+            <a:off x="8778240" y="5065776"/>
+            <a:ext cx="2606040" cy="411480"/>
+          </a:xfrm>
+          <a:prstGeom prst="rect">
+            <a:avLst/>
+          </a:prstGeom>
+          <a:noFill/>
+        </p:spPr>
+        <p:txBody>
+          <a:bodyPr wrap="square">
+            <a:spAutoFit/>
+          </a:bodyPr>
+          <a:lstStyle/>
+          <a:p>
+            <a:pPr algn="r"/>
+            <a:r>
+              <a:rPr sz="1500" b="0" i="0">
+                <a:solidFill>
+                  <a:srgbClr val="1D2A21"/>
+                </a:solidFill>
+                <a:latin typeface="Trebuchet MS"/>
+              </a:rPr>
+              <a:t>not billed yet</a:t>
+            </a:r>
+          </a:p>
+        </p:txBody>
+      </p:sp>
+      <p:sp>
+        <p:nvSpPr>
+          <p:cNvPr id="26" name="Rounded Rectangle 25"/>
           <p:cNvSpPr/>
           <p:nvPr/>
         </p:nvSpPr>
         <p:spPr>
           <a:xfrm>
-            <a:off x="777240" y="5486400"/>
-            <a:ext cx="10607040" cy="777240"/>
+            <a:off x="777240" y="5760720"/>
+            <a:ext cx="10607040" cy="502920"/>
           </a:xfrm>
           <a:prstGeom prst="roundRect">
             <a:avLst/>
@@ -4138,20 +4654,20 @@
           <a:p>
             <a:pPr algn="ctr"/>
             <a:r>
-              <a:rPr sz="1400" b="0" i="0">
+              <a:rPr sz="1300" b="0" i="0">
                 <a:solidFill>
                   <a:srgbClr val="19462B"/>
                 </a:solidFill>
                 <a:latin typeface="Trebuchet MS"/>
               </a:rPr>
-              <a:t>Exact figures are always in the AWS bill inside the account. Nothing here needs a purchase order.</a:t>
-            </a:r>
-          </a:p>
-        </p:txBody>
-      </p:sp>
-      <p:sp>
-        <p:nvSpPr>
-          <p:cNvPr id="8" name="TextBox 7"/>
+              <a:t>About $22 a year at today’s traffic — $6 of hosted zone plus the $16 name. Text messages are the one line that will grow.</a:t>
+            </a:r>
+          </a:p>
+        </p:txBody>
+      </p:sp>
+      <p:sp>
+        <p:nvSpPr>
+          <p:cNvPr id="27" name="TextBox 26"/>
           <p:cNvSpPr txBox="1"/>
           <p:nvPr/>
         </p:nvSpPr>
@@ -4186,7 +4702,7 @@
       </p:sp>
       <p:sp>
         <p:nvSpPr>
-          <p:cNvPr id="9" name="TextBox 8"/>
+          <p:cNvPr id="28" name="TextBox 27"/>
           <p:cNvSpPr txBox="1"/>
           <p:nvPr/>
         </p:nvSpPr>

</xml_diff>

<commit_message>
Deck: keep the edits made in PowerPoint, keep the corrected cost slide
Six edits had been made to the deck in PowerPoint: "/admin/" named on
slides 2 and 3, four punctuation changes, and organisation -> organization.
All six are kept, and applied to the source rather than only to the file,
so they survive the next rebuild.

The same saved file also carried slide 11 backwards. PowerPoint had the
document open from before the cost slide was corrected, so its save put
the old note text back and dropped the slide's footer. Regenerating from
source restores the corrected figures and keeps the six edits.

The generator is now committed beside the deck as
AAFA-website-overview.deck.py. It was the only copy of how the file is
built, and it lived in a scratch directory.

.gitignore now covers the ~$ lock files Office leaves behind while a
document is open, so one cannot be committed by accident.

Co-Authored-By: Claude Opus 5 <noreply@anthropic.com>
</commit_message>
<xml_diff>
--- a/docs/AAFA-website-overview.pptx
+++ b/docs/AAFA-website-overview.pptx
@@ -3582,7 +3582,7 @@
                 </a:solidFill>
                 <a:latin typeface="Trebuchet MS"/>
               </a:rPr>
-              <a:t>  One board member writes a message, a different one approves it. Nobody can approve their own.</a:t>
+              <a:t>  One board member writes a message; a different one approves it. Nobody can approve their own.</a:t>
             </a:r>
           </a:p>
           <a:p>
@@ -5436,7 +5436,7 @@
                 </a:solidFill>
                 <a:latin typeface="Trebuchet MS"/>
               </a:rPr>
-              <a:t>  The AWS account and the GitHub organisation are both owned by the Alliance, not by an individual.</a:t>
+              <a:t>  The AWS account and the GitHub organization are both owned by the Alliance, not by an individual.</a:t>
             </a:r>
           </a:p>
         </p:txBody>
@@ -5810,7 +5810,7 @@
                 </a:solidFill>
                 <a:latin typeface="Trebuchet MS"/>
               </a:rPr>
-              <a:t>Behind a locked door, board members type meeting notices, news articles, and messages to the membership.</a:t>
+              <a:t>Behind a locked door — the /admin/ part of the same website — board members type meeting notices, news articles, and messages to the membership.</a:t>
             </a:r>
           </a:p>
           <a:p>
@@ -6141,7 +6141,7 @@
                 </a:solidFill>
                 <a:latin typeface="Trebuchet MS"/>
               </a:rPr>
-              <a:t>BOARD MEMBER  —  signed in</a:t>
+              <a:t>BOARD MEMBER  —  signed in at /admin/</a:t>
             </a:r>
           </a:p>
         </p:txBody>
@@ -9980,7 +9980,7 @@
                 </a:solidFill>
                 <a:latin typeface="Trebuchet MS"/>
               </a:rPr>
-              <a:t>  Sends anything scheduled, and clears out sign-ups that were never confirmed.</a:t>
+              <a:t>  Sends anything scheduled and clears out sign-ups that were never confirmed.</a:t>
             </a:r>
           </a:p>
         </p:txBody>
@@ -10363,7 +10363,7 @@
                 </a:solidFill>
                 <a:latin typeface="Trebuchet MS"/>
               </a:rPr>
-              <a:t>  Adding somebody to the Board section does not give them access to edit the site, and removing them does not take it away.</a:t>
+              <a:t>  Adding somebody to the Board section does not give them access to edit the site and removing them does not take it away.</a:t>
             </a:r>
           </a:p>
           <a:p>
@@ -10431,7 +10431,7 @@
                 </a:solidFill>
                 <a:latin typeface="Trebuchet MS"/>
               </a:rPr>
-              <a:t>  Mark them as a past board member, and ask whoever manages the account to remove their login.</a:t>
+              <a:t>  Mark them as a past board member and ask whoever manages the account to remove their login.</a:t>
             </a:r>
           </a:p>
         </p:txBody>

</xml_diff>